<commit_message>
Mise à jour 2025
</commit_message>
<xml_diff>
--- a/coursIntro.pptx
+++ b/coursIntro.pptx
@@ -367,7 +367,7 @@
             </a:pPr>
             <a:fld id="{870BBE49-FCCB-4A90-A45C-67088542EE9F}" type="datetime1">
               <a:rPr lang="fr-FR" smtClean="0"/>
-              <a:t>04/09/2024</a:t>
+              <a:t>04/09/2025</a:t>
             </a:fld>
             <a:endParaRPr lang="fr-FR"/>
           </a:p>
@@ -602,7 +602,7 @@
             </a:pPr>
             <a:fld id="{B3571AEC-2BC4-4B6C-B79E-00D12817ECD9}" type="datetime1">
               <a:rPr lang="fr-FR" smtClean="0"/>
-              <a:t>04/09/2024</a:t>
+              <a:t>04/09/2025</a:t>
             </a:fld>
             <a:endParaRPr lang="fr-FR"/>
           </a:p>
@@ -1144,7 +1144,7 @@
             </a:pPr>
             <a:fld id="{046FFCB7-D57F-4C8C-BA32-2BA73F4500C6}" type="datetime1">
               <a:rPr lang="fr-FR" smtClean="0"/>
-              <a:t>04/09/2024</a:t>
+              <a:t>04/09/2025</a:t>
             </a:fld>
             <a:endParaRPr lang="fr-FR"/>
           </a:p>
@@ -1436,7 +1436,7 @@
             </a:pPr>
             <a:fld id="{CA852A4D-1BFF-498F-B63C-A36E50EC025B}" type="datetime1">
               <a:rPr lang="fr-FR" smtClean="0"/>
-              <a:t>04/09/2024</a:t>
+              <a:t>04/09/2025</a:t>
             </a:fld>
             <a:endParaRPr lang="fr-FR"/>
           </a:p>
@@ -2029,7 +2029,7 @@
             </a:br>
             <a:r>
               <a:rPr lang="fr-FR" altLang="fr-FR" dirty="0"/>
-              <a:t>Septembre 2024</a:t>
+              <a:t>Septembre 2025</a:t>
             </a:r>
             <a:br>
               <a:rPr lang="fr-FR" altLang="fr-FR" dirty="0"/>
@@ -2929,7 +2929,7 @@
           <p:nvPr>
             <p:extLst>
               <p:ext uri="{D42A27DB-BD31-4B8C-83A1-F6EECF244321}">
-                <p14:modId xmlns:p14="http://schemas.microsoft.com/office/powerpoint/2010/main" val="538973864"/>
+                <p14:modId xmlns:p14="http://schemas.microsoft.com/office/powerpoint/2010/main" val="2694647265"/>
               </p:ext>
             </p:extLst>
           </p:nvPr>
@@ -3209,7 +3209,7 @@
                           <a:effectLst/>
                           <a:latin typeface="Liberation Sans" panose="020B0604020202020204" pitchFamily="34" charset="0"/>
                         </a:rPr>
-                        <a:t>9/9</a:t>
+                        <a:t>8/9</a:t>
                       </a:r>
                     </a:p>
                   </a:txBody>
@@ -3394,7 +3394,7 @@
                           <a:effectLst/>
                           <a:latin typeface="Liberation Sans" panose="020B0604020202020204" pitchFamily="34" charset="0"/>
                         </a:rPr>
-                        <a:t>16/9</a:t>
+                        <a:t>15/9</a:t>
                       </a:r>
                     </a:p>
                   </a:txBody>
@@ -3579,7 +3579,7 @@
                           <a:effectLst/>
                           <a:latin typeface="Liberation Sans" panose="020B0604020202020204" pitchFamily="34" charset="0"/>
                         </a:rPr>
-                        <a:t>23/9</a:t>
+                        <a:t>22/9</a:t>
                       </a:r>
                     </a:p>
                   </a:txBody>
@@ -3748,7 +3748,7 @@
                           <a:effectLst/>
                           <a:latin typeface="Liberation Sans" panose="020B0604020202020204" pitchFamily="34" charset="0"/>
                         </a:rPr>
-                        <a:t>30/9</a:t>
+                        <a:t>29/9</a:t>
                       </a:r>
                     </a:p>
                   </a:txBody>
@@ -3917,7 +3917,7 @@
                           <a:effectLst/>
                           <a:latin typeface="Liberation Sans" panose="020B0604020202020204" pitchFamily="34" charset="0"/>
                         </a:rPr>
-                        <a:t>7/10</a:t>
+                        <a:t>6/10</a:t>
                       </a:r>
                     </a:p>
                   </a:txBody>
@@ -4086,7 +4086,7 @@
                           <a:effectLst/>
                           <a:latin typeface="Liberation Sans" panose="020B0604020202020204" pitchFamily="34" charset="0"/>
                         </a:rPr>
-                        <a:t>17/10</a:t>
+                        <a:t>13/10</a:t>
                       </a:r>
                     </a:p>
                   </a:txBody>
@@ -4271,7 +4271,7 @@
                           <a:effectLst/>
                           <a:latin typeface="Liberation Sans" panose="020B0604020202020204" pitchFamily="34" charset="0"/>
                         </a:rPr>
-                        <a:t>21/10</a:t>
+                        <a:t>20/10</a:t>
                       </a:r>
                     </a:p>
                   </a:txBody>
@@ -4459,7 +4459,7 @@
                           <a:effectLst/>
                           <a:latin typeface="Liberation Sans" panose="020B0604020202020204" pitchFamily="34" charset="0"/>
                         </a:rPr>
-                        <a:t>4/11</a:t>
+                        <a:t>3/11</a:t>
                       </a:r>
                     </a:p>
                   </a:txBody>
@@ -4644,7 +4644,7 @@
                           <a:effectLst/>
                           <a:latin typeface="Liberation Sans" panose="020B0604020202020204" pitchFamily="34" charset="0"/>
                         </a:rPr>
-                        <a:t>20/11</a:t>
+                        <a:t>10/11</a:t>
                       </a:r>
                     </a:p>
                   </a:txBody>
@@ -4813,7 +4813,7 @@
                           <a:effectLst/>
                           <a:latin typeface="Liberation Sans" panose="020B0604020202020204" pitchFamily="34" charset="0"/>
                         </a:rPr>
-                        <a:t>27/11</a:t>
+                        <a:t>17/11</a:t>
                       </a:r>
                     </a:p>
                   </a:txBody>
@@ -4982,7 +4982,7 @@
                           <a:effectLst/>
                           <a:latin typeface="Liberation Sans" panose="020B0604020202020204" pitchFamily="34" charset="0"/>
                         </a:rPr>
-                        <a:t>4/12</a:t>
+                        <a:t>24/11</a:t>
                       </a:r>
                     </a:p>
                   </a:txBody>
@@ -5150,12 +5150,16 @@
                     <a:p>
                       <a:pPr algn="l"/>
                       <a:r>
-                        <a:rPr lang="fr-FR" sz="1700" dirty="0">
+                        <a:rPr lang="fr-FR" sz="1700">
                           <a:effectLst/>
                           <a:latin typeface="Liberation Sans" panose="020B0604020202020204" pitchFamily="34" charset="0"/>
                         </a:rPr>
-                        <a:t>11/12</a:t>
+                        <a:t>1/12</a:t>
                       </a:r>
+                      <a:endParaRPr lang="fr-FR" sz="1700" dirty="0">
+                        <a:effectLst/>
+                        <a:latin typeface="Liberation Sans" panose="020B0604020202020204" pitchFamily="34" charset="0"/>
+                      </a:endParaRPr>
                     </a:p>
                   </a:txBody>
                   <a:tcPr marL="87038" marR="87038" marT="43519" marB="43519" anchor="ctr">

</xml_diff>